<commit_message>
Add BCM evolution plots
</commit_message>
<xml_diff>
--- a/challenges/optimisation/fast-approximate/Presentation3.pptx
+++ b/challenges/optimisation/fast-approximate/Presentation3.pptx
@@ -7,7 +7,8 @@
   <p:sldIdLst>
     <p:sldId id="256" r:id="rId2"/>
     <p:sldId id="257" r:id="rId3"/>
-    <p:sldId id="258" r:id="rId4"/>
+    <p:sldId id="259" r:id="rId4"/>
+    <p:sldId id="258" r:id="rId5"/>
   </p:sldIdLst>
   <p:sldSz cx="12192000" cy="6858000"/>
   <p:notesSz cx="6858000" cy="9144000"/>
@@ -106,6 +107,11 @@
       </a:defRPr>
     </a:lvl9pPr>
   </p:defaultTextStyle>
+  <p:extLst>
+    <p:ext uri="{EFAFB233-063F-42B5-8137-9DF3F51BA10A}">
+      <p15:sldGuideLst xmlns:p15="http://schemas.microsoft.com/office/powerpoint/2012/main"/>
+    </p:ext>
+  </p:extLst>
 </p:presentation>
 </file>
 
@@ -256,7 +262,7 @@
           <a:p>
             <a:fld id="{E305E294-B2CE-E34C-9C9F-DCAECEC52AD9}" type="datetimeFigureOut">
               <a:rPr lang="en-US" smtClean="0"/>
-              <a:t>10/13/26</a:t>
+              <a:t>10/13/2026</a:t>
             </a:fld>
             <a:endParaRPr lang="en-US"/>
           </a:p>
@@ -454,7 +460,7 @@
           <a:p>
             <a:fld id="{E305E294-B2CE-E34C-9C9F-DCAECEC52AD9}" type="datetimeFigureOut">
               <a:rPr lang="en-US" smtClean="0"/>
-              <a:t>10/13/26</a:t>
+              <a:t>10/13/2026</a:t>
             </a:fld>
             <a:endParaRPr lang="en-US"/>
           </a:p>
@@ -662,7 +668,7 @@
           <a:p>
             <a:fld id="{E305E294-B2CE-E34C-9C9F-DCAECEC52AD9}" type="datetimeFigureOut">
               <a:rPr lang="en-US" smtClean="0"/>
-              <a:t>10/13/26</a:t>
+              <a:t>10/13/2026</a:t>
             </a:fld>
             <a:endParaRPr lang="en-US"/>
           </a:p>
@@ -860,7 +866,7 @@
           <a:p>
             <a:fld id="{E305E294-B2CE-E34C-9C9F-DCAECEC52AD9}" type="datetimeFigureOut">
               <a:rPr lang="en-US" smtClean="0"/>
-              <a:t>10/13/26</a:t>
+              <a:t>10/13/2026</a:t>
             </a:fld>
             <a:endParaRPr lang="en-US"/>
           </a:p>
@@ -1135,7 +1141,7 @@
           <a:p>
             <a:fld id="{E305E294-B2CE-E34C-9C9F-DCAECEC52AD9}" type="datetimeFigureOut">
               <a:rPr lang="en-US" smtClean="0"/>
-              <a:t>10/13/26</a:t>
+              <a:t>10/13/2026</a:t>
             </a:fld>
             <a:endParaRPr lang="en-US"/>
           </a:p>
@@ -1400,7 +1406,7 @@
           <a:p>
             <a:fld id="{E305E294-B2CE-E34C-9C9F-DCAECEC52AD9}" type="datetimeFigureOut">
               <a:rPr lang="en-US" smtClean="0"/>
-              <a:t>10/13/26</a:t>
+              <a:t>10/13/2026</a:t>
             </a:fld>
             <a:endParaRPr lang="en-US"/>
           </a:p>
@@ -1812,7 +1818,7 @@
           <a:p>
             <a:fld id="{E305E294-B2CE-E34C-9C9F-DCAECEC52AD9}" type="datetimeFigureOut">
               <a:rPr lang="en-US" smtClean="0"/>
-              <a:t>10/13/26</a:t>
+              <a:t>10/13/2026</a:t>
             </a:fld>
             <a:endParaRPr lang="en-US"/>
           </a:p>
@@ -1953,7 +1959,7 @@
           <a:p>
             <a:fld id="{E305E294-B2CE-E34C-9C9F-DCAECEC52AD9}" type="datetimeFigureOut">
               <a:rPr lang="en-US" smtClean="0"/>
-              <a:t>10/13/26</a:t>
+              <a:t>10/13/2026</a:t>
             </a:fld>
             <a:endParaRPr lang="en-US"/>
           </a:p>
@@ -2066,7 +2072,7 @@
           <a:p>
             <a:fld id="{E305E294-B2CE-E34C-9C9F-DCAECEC52AD9}" type="datetimeFigureOut">
               <a:rPr lang="en-US" smtClean="0"/>
-              <a:t>10/13/26</a:t>
+              <a:t>10/13/2026</a:t>
             </a:fld>
             <a:endParaRPr lang="en-US"/>
           </a:p>
@@ -2377,7 +2383,7 @@
           <a:p>
             <a:fld id="{E305E294-B2CE-E34C-9C9F-DCAECEC52AD9}" type="datetimeFigureOut">
               <a:rPr lang="en-US" smtClean="0"/>
-              <a:t>10/13/26</a:t>
+              <a:t>10/13/2026</a:t>
             </a:fld>
             <a:endParaRPr lang="en-US"/>
           </a:p>
@@ -2665,7 +2671,7 @@
           <a:p>
             <a:fld id="{E305E294-B2CE-E34C-9C9F-DCAECEC52AD9}" type="datetimeFigureOut">
               <a:rPr lang="en-US" smtClean="0"/>
-              <a:t>10/13/26</a:t>
+              <a:t>10/13/2026</a:t>
             </a:fld>
             <a:endParaRPr lang="en-US"/>
           </a:p>
@@ -2906,7 +2912,7 @@
           <a:p>
             <a:fld id="{E305E294-B2CE-E34C-9C9F-DCAECEC52AD9}" type="datetimeFigureOut">
               <a:rPr lang="en-US" smtClean="0"/>
-              <a:t>10/13/26</a:t>
+              <a:t>10/13/2026</a:t>
             </a:fld>
             <a:endParaRPr lang="en-US"/>
           </a:p>
@@ -3462,6 +3468,13 @@
               <a:rPr lang="en-US" dirty="0"/>
               <a:t>Dataset Meaning</a:t>
             </a:r>
+            <a:endParaRPr lang="sl-SI" dirty="0"/>
+          </a:p>
+          <a:p>
+            <a:pPr marL="0" indent="0">
+              <a:buNone/>
+            </a:pPr>
+            <a:endParaRPr lang="en-US" dirty="0"/>
           </a:p>
         </p:txBody>
       </p:sp>
@@ -3479,6 +3492,93 @@
 </file>
 
 <file path=ppt/slides/slide3.xml><?xml version="1.0" encoding="utf-8"?>
+<p:sld xmlns:a="http://schemas.openxmlformats.org/drawingml/2006/main" xmlns:r="http://schemas.openxmlformats.org/officeDocument/2006/relationships" xmlns:p="http://schemas.openxmlformats.org/presentationml/2006/main">
+  <p:cSld>
+    <p:spTree>
+      <p:nvGrpSpPr>
+        <p:cNvPr id="1" name=""/>
+        <p:cNvGrpSpPr/>
+        <p:nvPr/>
+      </p:nvGrpSpPr>
+      <p:grpSpPr>
+        <a:xfrm>
+          <a:off x="0" y="0"/>
+          <a:ext cx="0" cy="0"/>
+          <a:chOff x="0" y="0"/>
+          <a:chExt cx="0" cy="0"/>
+        </a:xfrm>
+      </p:grpSpPr>
+      <p:sp>
+        <p:nvSpPr>
+          <p:cNvPr id="2" name="Title 1">
+            <a:extLst>
+              <a:ext uri="{FF2B5EF4-FFF2-40B4-BE49-F238E27FC236}">
+                <a16:creationId xmlns:a16="http://schemas.microsoft.com/office/drawing/2014/main" id="{A0456162-BBAA-FB4F-F018-2F860F966997}"/>
+              </a:ext>
+            </a:extLst>
+          </p:cNvPr>
+          <p:cNvSpPr>
+            <a:spLocks noGrp="1"/>
+          </p:cNvSpPr>
+          <p:nvPr>
+            <p:ph type="title"/>
+          </p:nvPr>
+        </p:nvSpPr>
+        <p:spPr/>
+        <p:txBody>
+          <a:bodyPr/>
+          <a:lstStyle/>
+          <a:p>
+            <a:endParaRPr lang="sl-SI" dirty="0"/>
+          </a:p>
+        </p:txBody>
+      </p:sp>
+      <p:pic>
+        <p:nvPicPr>
+          <p:cNvPr id="7" name="Content Placeholder 6">
+            <a:extLst>
+              <a:ext uri="{FF2B5EF4-FFF2-40B4-BE49-F238E27FC236}">
+                <a16:creationId xmlns:a16="http://schemas.microsoft.com/office/drawing/2014/main" id="{30FB415A-17DF-70A8-1BCB-9CB0D0AE20B7}"/>
+              </a:ext>
+            </a:extLst>
+          </p:cNvPr>
+          <p:cNvPicPr>
+            <a:picLocks noGrp="1" noChangeAspect="1"/>
+          </p:cNvPicPr>
+          <p:nvPr>
+            <p:ph idx="1"/>
+          </p:nvPr>
+        </p:nvPicPr>
+        <p:blipFill>
+          <a:blip r:embed="rId2"/>
+          <a:stretch>
+            <a:fillRect/>
+          </a:stretch>
+        </p:blipFill>
+        <p:spPr>
+          <a:xfrm>
+            <a:off x="872901" y="150786"/>
+            <a:ext cx="10446198" cy="6556427"/>
+          </a:xfrm>
+          <a:prstGeom prst="rect">
+            <a:avLst/>
+          </a:prstGeom>
+        </p:spPr>
+      </p:pic>
+    </p:spTree>
+    <p:extLst>
+      <p:ext uri="{BB962C8B-B14F-4D97-AF65-F5344CB8AC3E}">
+        <p14:creationId xmlns:p14="http://schemas.microsoft.com/office/powerpoint/2010/main" val="2841332456"/>
+      </p:ext>
+    </p:extLst>
+  </p:cSld>
+  <p:clrMapOvr>
+    <a:masterClrMapping/>
+  </p:clrMapOvr>
+</p:sld>
+</file>
+
+<file path=ppt/slides/slide4.xml><?xml version="1.0" encoding="utf-8"?>
 <p:sld xmlns:a="http://schemas.openxmlformats.org/drawingml/2006/main" xmlns:r="http://schemas.openxmlformats.org/officeDocument/2006/relationships" xmlns:p="http://schemas.openxmlformats.org/presentationml/2006/main">
   <p:cSld>
     <p:spTree>

</xml_diff>

<commit_message>
Adding some visualization and ppt
</commit_message>
<xml_diff>
--- a/challenges/optimisation/fast-approximate/Presentation3.pptx
+++ b/challenges/optimisation/fast-approximate/Presentation3.pptx
@@ -7,18 +7,19 @@
   <p:sldIdLst>
     <p:sldId id="256" r:id="rId2"/>
     <p:sldId id="257" r:id="rId3"/>
-    <p:sldId id="258" r:id="rId4"/>
-    <p:sldId id="261" r:id="rId5"/>
-    <p:sldId id="260" r:id="rId6"/>
-    <p:sldId id="264" r:id="rId7"/>
-    <p:sldId id="265" r:id="rId8"/>
-    <p:sldId id="266" r:id="rId9"/>
-    <p:sldId id="267" r:id="rId10"/>
-    <p:sldId id="268" r:id="rId11"/>
-    <p:sldId id="263" r:id="rId12"/>
-    <p:sldId id="269" r:id="rId13"/>
-    <p:sldId id="262" r:id="rId14"/>
-    <p:sldId id="259" r:id="rId15"/>
+    <p:sldId id="270" r:id="rId4"/>
+    <p:sldId id="258" r:id="rId5"/>
+    <p:sldId id="261" r:id="rId6"/>
+    <p:sldId id="260" r:id="rId7"/>
+    <p:sldId id="264" r:id="rId8"/>
+    <p:sldId id="265" r:id="rId9"/>
+    <p:sldId id="266" r:id="rId10"/>
+    <p:sldId id="267" r:id="rId11"/>
+    <p:sldId id="268" r:id="rId12"/>
+    <p:sldId id="263" r:id="rId13"/>
+    <p:sldId id="269" r:id="rId14"/>
+    <p:sldId id="262" r:id="rId15"/>
+    <p:sldId id="259" r:id="rId16"/>
   </p:sldIdLst>
   <p:sldSz cx="12192000" cy="6858000"/>
   <p:notesSz cx="6858000" cy="9144000"/>
@@ -272,7 +273,7 @@
           <a:p>
             <a:fld id="{E305E294-B2CE-E34C-9C9F-DCAECEC52AD9}" type="datetimeFigureOut">
               <a:rPr lang="en-US" smtClean="0"/>
-              <a:t>10/14/26</a:t>
+              <a:t>10/15/26</a:t>
             </a:fld>
             <a:endParaRPr lang="en-US"/>
           </a:p>
@@ -470,7 +471,7 @@
           <a:p>
             <a:fld id="{E305E294-B2CE-E34C-9C9F-DCAECEC52AD9}" type="datetimeFigureOut">
               <a:rPr lang="en-US" smtClean="0"/>
-              <a:t>10/14/26</a:t>
+              <a:t>10/15/26</a:t>
             </a:fld>
             <a:endParaRPr lang="en-US"/>
           </a:p>
@@ -678,7 +679,7 @@
           <a:p>
             <a:fld id="{E305E294-B2CE-E34C-9C9F-DCAECEC52AD9}" type="datetimeFigureOut">
               <a:rPr lang="en-US" smtClean="0"/>
-              <a:t>10/14/26</a:t>
+              <a:t>10/15/26</a:t>
             </a:fld>
             <a:endParaRPr lang="en-US"/>
           </a:p>
@@ -876,7 +877,7 @@
           <a:p>
             <a:fld id="{E305E294-B2CE-E34C-9C9F-DCAECEC52AD9}" type="datetimeFigureOut">
               <a:rPr lang="en-US" smtClean="0"/>
-              <a:t>10/14/26</a:t>
+              <a:t>10/15/26</a:t>
             </a:fld>
             <a:endParaRPr lang="en-US"/>
           </a:p>
@@ -1151,7 +1152,7 @@
           <a:p>
             <a:fld id="{E305E294-B2CE-E34C-9C9F-DCAECEC52AD9}" type="datetimeFigureOut">
               <a:rPr lang="en-US" smtClean="0"/>
-              <a:t>10/14/26</a:t>
+              <a:t>10/15/26</a:t>
             </a:fld>
             <a:endParaRPr lang="en-US"/>
           </a:p>
@@ -1416,7 +1417,7 @@
           <a:p>
             <a:fld id="{E305E294-B2CE-E34C-9C9F-DCAECEC52AD9}" type="datetimeFigureOut">
               <a:rPr lang="en-US" smtClean="0"/>
-              <a:t>10/14/26</a:t>
+              <a:t>10/15/26</a:t>
             </a:fld>
             <a:endParaRPr lang="en-US"/>
           </a:p>
@@ -1828,7 +1829,7 @@
           <a:p>
             <a:fld id="{E305E294-B2CE-E34C-9C9F-DCAECEC52AD9}" type="datetimeFigureOut">
               <a:rPr lang="en-US" smtClean="0"/>
-              <a:t>10/14/26</a:t>
+              <a:t>10/15/26</a:t>
             </a:fld>
             <a:endParaRPr lang="en-US"/>
           </a:p>
@@ -1969,7 +1970,7 @@
           <a:p>
             <a:fld id="{E305E294-B2CE-E34C-9C9F-DCAECEC52AD9}" type="datetimeFigureOut">
               <a:rPr lang="en-US" smtClean="0"/>
-              <a:t>10/14/26</a:t>
+              <a:t>10/15/26</a:t>
             </a:fld>
             <a:endParaRPr lang="en-US"/>
           </a:p>
@@ -2082,7 +2083,7 @@
           <a:p>
             <a:fld id="{E305E294-B2CE-E34C-9C9F-DCAECEC52AD9}" type="datetimeFigureOut">
               <a:rPr lang="en-US" smtClean="0"/>
-              <a:t>10/14/26</a:t>
+              <a:t>10/15/26</a:t>
             </a:fld>
             <a:endParaRPr lang="en-US"/>
           </a:p>
@@ -2393,7 +2394,7 @@
           <a:p>
             <a:fld id="{E305E294-B2CE-E34C-9C9F-DCAECEC52AD9}" type="datetimeFigureOut">
               <a:rPr lang="en-US" smtClean="0"/>
-              <a:t>10/14/26</a:t>
+              <a:t>10/15/26</a:t>
             </a:fld>
             <a:endParaRPr lang="en-US"/>
           </a:p>
@@ -2681,7 +2682,7 @@
           <a:p>
             <a:fld id="{E305E294-B2CE-E34C-9C9F-DCAECEC52AD9}" type="datetimeFigureOut">
               <a:rPr lang="en-US" smtClean="0"/>
-              <a:t>10/14/26</a:t>
+              <a:t>10/15/26</a:t>
             </a:fld>
             <a:endParaRPr lang="en-US"/>
           </a:p>
@@ -2922,7 +2923,7 @@
           <a:p>
             <a:fld id="{E305E294-B2CE-E34C-9C9F-DCAECEC52AD9}" type="datetimeFigureOut">
               <a:rPr lang="en-US" smtClean="0"/>
-              <a:t>10/14/26</a:t>
+              <a:t>10/15/26</a:t>
             </a:fld>
             <a:endParaRPr lang="en-US"/>
           </a:p>
@@ -3416,6 +3417,72 @@
         <p:cNvPr id="1" name="">
           <a:extLst>
             <a:ext uri="{FF2B5EF4-FFF2-40B4-BE49-F238E27FC236}">
+              <a16:creationId xmlns:a16="http://schemas.microsoft.com/office/drawing/2014/main" id="{DB6AD056-8137-47DA-761D-57C82B8CFD4B}"/>
+            </a:ext>
+          </a:extLst>
+        </p:cNvPr>
+        <p:cNvGrpSpPr/>
+        <p:nvPr/>
+      </p:nvGrpSpPr>
+      <p:grpSpPr>
+        <a:xfrm>
+          <a:off x="0" y="0"/>
+          <a:ext cx="0" cy="0"/>
+          <a:chOff x="0" y="0"/>
+          <a:chExt cx="0" cy="0"/>
+        </a:xfrm>
+      </p:grpSpPr>
+      <p:pic>
+        <p:nvPicPr>
+          <p:cNvPr id="2" name="Picture 1">
+            <a:extLst>
+              <a:ext uri="{FF2B5EF4-FFF2-40B4-BE49-F238E27FC236}">
+                <a16:creationId xmlns:a16="http://schemas.microsoft.com/office/drawing/2014/main" id="{699F7CE8-00E7-CBCC-F1D6-9961FF4F76AB}"/>
+              </a:ext>
+            </a:extLst>
+          </p:cNvPr>
+          <p:cNvPicPr>
+            <a:picLocks noChangeAspect="1"/>
+          </p:cNvPicPr>
+          <p:nvPr/>
+        </p:nvPicPr>
+        <p:blipFill>
+          <a:blip r:embed="rId2"/>
+          <a:stretch>
+            <a:fillRect/>
+          </a:stretch>
+        </p:blipFill>
+        <p:spPr>
+          <a:xfrm>
+            <a:off x="2514600" y="1978310"/>
+            <a:ext cx="7772400" cy="3510980"/>
+          </a:xfrm>
+          <a:prstGeom prst="rect">
+            <a:avLst/>
+          </a:prstGeom>
+        </p:spPr>
+      </p:pic>
+    </p:spTree>
+    <p:extLst>
+      <p:ext uri="{BB962C8B-B14F-4D97-AF65-F5344CB8AC3E}">
+        <p14:creationId xmlns:p14="http://schemas.microsoft.com/office/powerpoint/2010/main" val="2029763607"/>
+      </p:ext>
+    </p:extLst>
+  </p:cSld>
+  <p:clrMapOvr>
+    <a:masterClrMapping/>
+  </p:clrMapOvr>
+</p:sld>
+</file>
+
+<file path=ppt/slides/slide11.xml><?xml version="1.0" encoding="utf-8"?>
+<p:sld xmlns:a="http://schemas.openxmlformats.org/drawingml/2006/main" xmlns:r="http://schemas.openxmlformats.org/officeDocument/2006/relationships" xmlns:p="http://schemas.openxmlformats.org/presentationml/2006/main">
+  <p:cSld>
+    <p:spTree>
+      <p:nvGrpSpPr>
+        <p:cNvPr id="1" name="">
+          <a:extLst>
+            <a:ext uri="{FF2B5EF4-FFF2-40B4-BE49-F238E27FC236}">
               <a16:creationId xmlns:a16="http://schemas.microsoft.com/office/drawing/2014/main" id="{F6A8E9B1-A136-74F3-C07E-D09D521A2FA0}"/>
             </a:ext>
           </a:extLst>
@@ -3474,7 +3541,7 @@
 </p:sld>
 </file>
 
-<file path=ppt/slides/slide11.xml><?xml version="1.0" encoding="utf-8"?>
+<file path=ppt/slides/slide12.xml><?xml version="1.0" encoding="utf-8"?>
 <p:sld xmlns:a="http://schemas.openxmlformats.org/drawingml/2006/main" xmlns:r="http://schemas.openxmlformats.org/officeDocument/2006/relationships" xmlns:p="http://schemas.openxmlformats.org/presentationml/2006/main">
   <p:cSld>
     <p:spTree>
@@ -3540,7 +3607,7 @@
 </p:sld>
 </file>
 
-<file path=ppt/slides/slide12.xml><?xml version="1.0" encoding="utf-8"?>
+<file path=ppt/slides/slide13.xml><?xml version="1.0" encoding="utf-8"?>
 <p:sld xmlns:a="http://schemas.openxmlformats.org/drawingml/2006/main" xmlns:r="http://schemas.openxmlformats.org/officeDocument/2006/relationships" xmlns:p="http://schemas.openxmlformats.org/presentationml/2006/main">
   <p:cSld>
     <p:spTree>
@@ -3606,7 +3673,7 @@
 </p:sld>
 </file>
 
-<file path=ppt/slides/slide13.xml><?xml version="1.0" encoding="utf-8"?>
+<file path=ppt/slides/slide14.xml><?xml version="1.0" encoding="utf-8"?>
 <p:sld xmlns:a="http://schemas.openxmlformats.org/drawingml/2006/main" xmlns:r="http://schemas.openxmlformats.org/officeDocument/2006/relationships" xmlns:p="http://schemas.openxmlformats.org/presentationml/2006/main">
   <p:cSld>
     <p:spTree>
@@ -3666,7 +3733,7 @@
 </p:sld>
 </file>
 
-<file path=ppt/slides/slide14.xml><?xml version="1.0" encoding="utf-8"?>
+<file path=ppt/slides/slide15.xml><?xml version="1.0" encoding="utf-8"?>
 <p:sld xmlns:a="http://schemas.openxmlformats.org/drawingml/2006/main" xmlns:r="http://schemas.openxmlformats.org/officeDocument/2006/relationships" xmlns:p="http://schemas.openxmlformats.org/presentationml/2006/main">
   <p:cSld>
     <p:spTree>
@@ -4005,6 +4072,332 @@
         <p:cNvPr id="1" name="">
           <a:extLst>
             <a:ext uri="{FF2B5EF4-FFF2-40B4-BE49-F238E27FC236}">
+              <a16:creationId xmlns:a16="http://schemas.microsoft.com/office/drawing/2014/main" id="{99EDC61A-B5BB-376C-79F3-2937C34A7FFF}"/>
+            </a:ext>
+          </a:extLst>
+        </p:cNvPr>
+        <p:cNvGrpSpPr/>
+        <p:nvPr/>
+      </p:nvGrpSpPr>
+      <p:grpSpPr>
+        <a:xfrm>
+          <a:off x="0" y="0"/>
+          <a:ext cx="0" cy="0"/>
+          <a:chOff x="0" y="0"/>
+          <a:chExt cx="0" cy="0"/>
+        </a:xfrm>
+      </p:grpSpPr>
+      <p:sp>
+        <p:nvSpPr>
+          <p:cNvPr id="6" name="Title 5">
+            <a:extLst>
+              <a:ext uri="{FF2B5EF4-FFF2-40B4-BE49-F238E27FC236}">
+                <a16:creationId xmlns:a16="http://schemas.microsoft.com/office/drawing/2014/main" id="{32208B62-DCE7-2265-E37F-DED5FF028027}"/>
+              </a:ext>
+            </a:extLst>
+          </p:cNvPr>
+          <p:cNvSpPr>
+            <a:spLocks noGrp="1"/>
+          </p:cNvSpPr>
+          <p:nvPr>
+            <p:ph type="title"/>
+          </p:nvPr>
+        </p:nvSpPr>
+        <p:spPr/>
+        <p:txBody>
+          <a:bodyPr/>
+          <a:lstStyle/>
+          <a:p>
+            <a:r>
+              <a:rPr lang="en-US" dirty="0"/>
+              <a:t>OUTLINE	</a:t>
+            </a:r>
+          </a:p>
+        </p:txBody>
+      </p:sp>
+      <p:sp>
+        <p:nvSpPr>
+          <p:cNvPr id="8" name="Content Placeholder 7">
+            <a:extLst>
+              <a:ext uri="{FF2B5EF4-FFF2-40B4-BE49-F238E27FC236}">
+                <a16:creationId xmlns:a16="http://schemas.microsoft.com/office/drawing/2014/main" id="{15447D77-1E0A-4AB7-D2A4-03D04DDABC30}"/>
+              </a:ext>
+            </a:extLst>
+          </p:cNvPr>
+          <p:cNvSpPr>
+            <a:spLocks noGrp="1"/>
+          </p:cNvSpPr>
+          <p:nvPr>
+            <p:ph idx="1"/>
+          </p:nvPr>
+        </p:nvSpPr>
+        <p:spPr>
+          <a:xfrm>
+            <a:off x="838200" y="1460500"/>
+            <a:ext cx="10515600" cy="5032375"/>
+          </a:xfrm>
+        </p:spPr>
+        <p:txBody>
+          <a:bodyPr>
+            <a:normAutofit fontScale="92500" lnSpcReduction="20000"/>
+          </a:bodyPr>
+          <a:lstStyle/>
+          <a:p>
+            <a:r>
+              <a:rPr lang="en-US" sz="1400" dirty="0"/>
+              <a:t>Problem Introduction</a:t>
+            </a:r>
+          </a:p>
+          <a:p>
+            <a:r>
+              <a:rPr lang="en-US" sz="1400" b="1" dirty="0"/>
+              <a:t>Easy task:</a:t>
+            </a:r>
+          </a:p>
+          <a:p>
+            <a:pPr lvl="1"/>
+            <a:r>
+              <a:rPr lang="en-US" sz="1200" b="1" dirty="0">
+                <a:solidFill>
+                  <a:srgbClr val="FF0000"/>
+                </a:solidFill>
+              </a:rPr>
+              <a:t>Problem description</a:t>
+            </a:r>
+          </a:p>
+          <a:p>
+            <a:pPr lvl="1"/>
+            <a:r>
+              <a:rPr lang="en-US" sz="1200" b="1" dirty="0"/>
+              <a:t>Data handling</a:t>
+            </a:r>
+          </a:p>
+          <a:p>
+            <a:pPr lvl="1"/>
+            <a:r>
+              <a:rPr lang="en-US" sz="1200" b="1" dirty="0"/>
+              <a:t>Data cleaning </a:t>
+            </a:r>
+          </a:p>
+          <a:p>
+            <a:pPr lvl="1"/>
+            <a:r>
+              <a:rPr lang="en-US" sz="1200" b="1" dirty="0"/>
+              <a:t>Main challenges</a:t>
+            </a:r>
+          </a:p>
+          <a:p>
+            <a:r>
+              <a:rPr lang="en-US" sz="1400" dirty="0"/>
+              <a:t>Medium Task	</a:t>
+            </a:r>
+          </a:p>
+          <a:p>
+            <a:pPr lvl="1"/>
+            <a:r>
+              <a:rPr lang="en-US" sz="1200" dirty="0">
+                <a:solidFill>
+                  <a:srgbClr val="FF0000"/>
+                </a:solidFill>
+              </a:rPr>
+              <a:t>Problem description</a:t>
+            </a:r>
+          </a:p>
+          <a:p>
+            <a:pPr lvl="1"/>
+            <a:r>
+              <a:rPr lang="en-US" sz="1200" dirty="0"/>
+              <a:t>Approach used</a:t>
+            </a:r>
+          </a:p>
+          <a:p>
+            <a:pPr lvl="1"/>
+            <a:r>
+              <a:rPr lang="en-US" sz="1200" dirty="0"/>
+              <a:t>Model results</a:t>
+            </a:r>
+          </a:p>
+          <a:p>
+            <a:pPr lvl="1"/>
+            <a:r>
+              <a:rPr lang="en-US" sz="1200" dirty="0"/>
+              <a:t>Main and open challenges</a:t>
+            </a:r>
+          </a:p>
+          <a:p>
+            <a:r>
+              <a:rPr lang="en-US" sz="1400" dirty="0"/>
+              <a:t>Hard Task	</a:t>
+            </a:r>
+          </a:p>
+          <a:p>
+            <a:pPr lvl="1"/>
+            <a:r>
+              <a:rPr lang="en-US" sz="1200" dirty="0">
+                <a:solidFill>
+                  <a:srgbClr val="FF0000"/>
+                </a:solidFill>
+              </a:rPr>
+              <a:t>Problem description</a:t>
+            </a:r>
+          </a:p>
+          <a:p>
+            <a:pPr lvl="1"/>
+            <a:r>
+              <a:rPr lang="en-US" sz="1200" dirty="0"/>
+              <a:t>Approach used</a:t>
+            </a:r>
+          </a:p>
+          <a:p>
+            <a:pPr lvl="1"/>
+            <a:r>
+              <a:rPr lang="en-US" sz="1200" dirty="0"/>
+              <a:t>Model results</a:t>
+            </a:r>
+          </a:p>
+          <a:p>
+            <a:pPr lvl="1"/>
+            <a:r>
+              <a:rPr lang="en-US" sz="1200" dirty="0"/>
+              <a:t>Main and open challenges</a:t>
+            </a:r>
+          </a:p>
+          <a:p>
+            <a:r>
+              <a:rPr lang="en-US" sz="1400" dirty="0"/>
+              <a:t>Conclusion &amp; Outlook	</a:t>
+            </a:r>
+          </a:p>
+          <a:p>
+            <a:pPr lvl="1"/>
+            <a:r>
+              <a:rPr lang="en-US" sz="1200" dirty="0"/>
+              <a:t>Conclusion</a:t>
+            </a:r>
+          </a:p>
+          <a:p>
+            <a:pPr lvl="2"/>
+            <a:r>
+              <a:rPr lang="en-US" sz="1100" dirty="0"/>
+              <a:t>What was done, what were the main challenges </a:t>
+            </a:r>
+          </a:p>
+          <a:p>
+            <a:pPr lvl="2"/>
+            <a:r>
+              <a:rPr lang="en-US" sz="1100" dirty="0"/>
+              <a:t>Colorful solution</a:t>
+            </a:r>
+          </a:p>
+          <a:p>
+            <a:pPr lvl="2"/>
+            <a:r>
+              <a:rPr lang="en-US" sz="1100" dirty="0"/>
+              <a:t>Highlights of the results</a:t>
+            </a:r>
+          </a:p>
+          <a:p>
+            <a:pPr lvl="1"/>
+            <a:r>
+              <a:rPr lang="en-US" sz="1200" dirty="0"/>
+              <a:t>Outlook</a:t>
+            </a:r>
+          </a:p>
+          <a:p>
+            <a:pPr lvl="2"/>
+            <a:r>
+              <a:rPr lang="en-US" sz="1100" dirty="0"/>
+              <a:t>Challenge identified</a:t>
+            </a:r>
+          </a:p>
+          <a:p>
+            <a:pPr lvl="2"/>
+            <a:r>
+              <a:rPr lang="en-US" sz="1100" dirty="0"/>
+              <a:t>Future scheduling work</a:t>
+            </a:r>
+          </a:p>
+        </p:txBody>
+      </p:sp>
+      <p:sp>
+        <p:nvSpPr>
+          <p:cNvPr id="9" name="TextBox 8">
+            <a:extLst>
+              <a:ext uri="{FF2B5EF4-FFF2-40B4-BE49-F238E27FC236}">
+                <a16:creationId xmlns:a16="http://schemas.microsoft.com/office/drawing/2014/main" id="{7CE812A6-C4A1-2557-4F8B-8023A115F6C3}"/>
+              </a:ext>
+            </a:extLst>
+          </p:cNvPr>
+          <p:cNvSpPr txBox="1"/>
+          <p:nvPr/>
+        </p:nvSpPr>
+        <p:spPr>
+          <a:xfrm>
+            <a:off x="7587342" y="1027906"/>
+            <a:ext cx="1179618" cy="1200329"/>
+          </a:xfrm>
+          <a:prstGeom prst="rect">
+            <a:avLst/>
+          </a:prstGeom>
+          <a:noFill/>
+        </p:spPr>
+        <p:txBody>
+          <a:bodyPr wrap="none" rtlCol="0">
+            <a:spAutoFit/>
+          </a:bodyPr>
+          <a:lstStyle/>
+          <a:p>
+            <a:r>
+              <a:rPr lang="en-US" b="1" dirty="0">
+                <a:solidFill>
+                  <a:srgbClr val="FF0000"/>
+                </a:solidFill>
+              </a:rPr>
+              <a:t>ANTONIO</a:t>
+            </a:r>
+          </a:p>
+          <a:p>
+            <a:r>
+              <a:rPr lang="en-US" dirty="0"/>
+              <a:t>ALEX </a:t>
+            </a:r>
+            <a:br>
+              <a:rPr lang="en-US" dirty="0"/>
+            </a:br>
+            <a:r>
+              <a:rPr lang="en-US" dirty="0"/>
+              <a:t>QUENTIN</a:t>
+            </a:r>
+          </a:p>
+          <a:p>
+            <a:r>
+              <a:rPr lang="en-US" dirty="0"/>
+              <a:t>JAN</a:t>
+            </a:r>
+          </a:p>
+        </p:txBody>
+      </p:sp>
+    </p:spTree>
+    <p:extLst>
+      <p:ext uri="{BB962C8B-B14F-4D97-AF65-F5344CB8AC3E}">
+        <p14:creationId xmlns:p14="http://schemas.microsoft.com/office/powerpoint/2010/main" val="2201460497"/>
+      </p:ext>
+    </p:extLst>
+  </p:cSld>
+  <p:clrMapOvr>
+    <a:masterClrMapping/>
+  </p:clrMapOvr>
+</p:sld>
+</file>
+
+<file path=ppt/slides/slide4.xml><?xml version="1.0" encoding="utf-8"?>
+<p:sld xmlns:a="http://schemas.openxmlformats.org/drawingml/2006/main" xmlns:r="http://schemas.openxmlformats.org/officeDocument/2006/relationships" xmlns:p="http://schemas.openxmlformats.org/presentationml/2006/main">
+  <p:cSld>
+    <p:spTree>
+      <p:nvGrpSpPr>
+        <p:cNvPr id="1" name="">
+          <a:extLst>
+            <a:ext uri="{FF2B5EF4-FFF2-40B4-BE49-F238E27FC236}">
               <a16:creationId xmlns:a16="http://schemas.microsoft.com/office/drawing/2014/main" id="{6520BC2B-9D36-8A3E-2596-669248DC6B42}"/>
             </a:ext>
           </a:extLst>
@@ -4142,7 +4535,7 @@
 </p:sld>
 </file>
 
-<file path=ppt/slides/slide4.xml><?xml version="1.0" encoding="utf-8"?>
+<file path=ppt/slides/slide5.xml><?xml version="1.0" encoding="utf-8"?>
 <p:sld xmlns:a="http://schemas.openxmlformats.org/drawingml/2006/main" xmlns:r="http://schemas.openxmlformats.org/officeDocument/2006/relationships" xmlns:p="http://schemas.openxmlformats.org/presentationml/2006/main">
   <p:cSld>
     <p:spTree>
@@ -4202,7 +4595,7 @@
 </p:sld>
 </file>
 
-<file path=ppt/slides/slide5.xml><?xml version="1.0" encoding="utf-8"?>
+<file path=ppt/slides/slide6.xml><?xml version="1.0" encoding="utf-8"?>
 <p:sld xmlns:a="http://schemas.openxmlformats.org/drawingml/2006/main" xmlns:r="http://schemas.openxmlformats.org/officeDocument/2006/relationships" xmlns:p="http://schemas.openxmlformats.org/presentationml/2006/main">
   <p:cSld>
     <p:spTree>
@@ -4263,7 +4656,7 @@
 </p:sld>
 </file>
 
-<file path=ppt/slides/slide6.xml><?xml version="1.0" encoding="utf-8"?>
+<file path=ppt/slides/slide7.xml><?xml version="1.0" encoding="utf-8"?>
 <p:sld xmlns:a="http://schemas.openxmlformats.org/drawingml/2006/main" xmlns:r="http://schemas.openxmlformats.org/officeDocument/2006/relationships" xmlns:p="http://schemas.openxmlformats.org/presentationml/2006/main">
   <p:cSld>
     <p:spTree>
@@ -4329,7 +4722,7 @@
 </p:sld>
 </file>
 
-<file path=ppt/slides/slide7.xml><?xml version="1.0" encoding="utf-8"?>
+<file path=ppt/slides/slide8.xml><?xml version="1.0" encoding="utf-8"?>
 <p:sld xmlns:a="http://schemas.openxmlformats.org/drawingml/2006/main" xmlns:r="http://schemas.openxmlformats.org/officeDocument/2006/relationships" xmlns:p="http://schemas.openxmlformats.org/presentationml/2006/main">
   <p:cSld>
     <p:spTree>
@@ -4395,7 +4788,7 @@
 </p:sld>
 </file>
 
-<file path=ppt/slides/slide8.xml><?xml version="1.0" encoding="utf-8"?>
+<file path=ppt/slides/slide9.xml><?xml version="1.0" encoding="utf-8"?>
 <p:sld xmlns:a="http://schemas.openxmlformats.org/drawingml/2006/main" xmlns:r="http://schemas.openxmlformats.org/officeDocument/2006/relationships" xmlns:p="http://schemas.openxmlformats.org/presentationml/2006/main">
   <p:cSld>
     <p:spTree>
@@ -4452,72 +4845,6 @@
     <p:extLst>
       <p:ext uri="{BB962C8B-B14F-4D97-AF65-F5344CB8AC3E}">
         <p14:creationId xmlns:p14="http://schemas.microsoft.com/office/powerpoint/2010/main" val="414943267"/>
-      </p:ext>
-    </p:extLst>
-  </p:cSld>
-  <p:clrMapOvr>
-    <a:masterClrMapping/>
-  </p:clrMapOvr>
-</p:sld>
-</file>
-
-<file path=ppt/slides/slide9.xml><?xml version="1.0" encoding="utf-8"?>
-<p:sld xmlns:a="http://schemas.openxmlformats.org/drawingml/2006/main" xmlns:r="http://schemas.openxmlformats.org/officeDocument/2006/relationships" xmlns:p="http://schemas.openxmlformats.org/presentationml/2006/main">
-  <p:cSld>
-    <p:spTree>
-      <p:nvGrpSpPr>
-        <p:cNvPr id="1" name="">
-          <a:extLst>
-            <a:ext uri="{FF2B5EF4-FFF2-40B4-BE49-F238E27FC236}">
-              <a16:creationId xmlns:a16="http://schemas.microsoft.com/office/drawing/2014/main" id="{DB6AD056-8137-47DA-761D-57C82B8CFD4B}"/>
-            </a:ext>
-          </a:extLst>
-        </p:cNvPr>
-        <p:cNvGrpSpPr/>
-        <p:nvPr/>
-      </p:nvGrpSpPr>
-      <p:grpSpPr>
-        <a:xfrm>
-          <a:off x="0" y="0"/>
-          <a:ext cx="0" cy="0"/>
-          <a:chOff x="0" y="0"/>
-          <a:chExt cx="0" cy="0"/>
-        </a:xfrm>
-      </p:grpSpPr>
-      <p:pic>
-        <p:nvPicPr>
-          <p:cNvPr id="2" name="Picture 1">
-            <a:extLst>
-              <a:ext uri="{FF2B5EF4-FFF2-40B4-BE49-F238E27FC236}">
-                <a16:creationId xmlns:a16="http://schemas.microsoft.com/office/drawing/2014/main" id="{699F7CE8-00E7-CBCC-F1D6-9961FF4F76AB}"/>
-              </a:ext>
-            </a:extLst>
-          </p:cNvPr>
-          <p:cNvPicPr>
-            <a:picLocks noChangeAspect="1"/>
-          </p:cNvPicPr>
-          <p:nvPr/>
-        </p:nvPicPr>
-        <p:blipFill>
-          <a:blip r:embed="rId2"/>
-          <a:stretch>
-            <a:fillRect/>
-          </a:stretch>
-        </p:blipFill>
-        <p:spPr>
-          <a:xfrm>
-            <a:off x="2514600" y="1978310"/>
-            <a:ext cx="7772400" cy="3510980"/>
-          </a:xfrm>
-          <a:prstGeom prst="rect">
-            <a:avLst/>
-          </a:prstGeom>
-        </p:spPr>
-      </p:pic>
-    </p:spTree>
-    <p:extLst>
-      <p:ext uri="{BB962C8B-B14F-4D97-AF65-F5344CB8AC3E}">
-        <p14:creationId xmlns:p14="http://schemas.microsoft.com/office/powerpoint/2010/main" val="2029763607"/>
       </p:ext>
     </p:extLst>
   </p:cSld>

</xml_diff>